<commit_message>
docs(presentation): redesign Feasibility & Viability slide into 4-quadrant executive summary
</commit_message>
<xml_diff>
--- a/docs/presentation/SIH26181_Official_Template_Presentation.pptx
+++ b/docs/presentation/SIH26181_Official_Template_Presentation.pptx
@@ -1,76 +1,5 @@
 
-<file path=docProps\app.xml><?xml version="1.0" encoding="utf-8"?>
-<Properties xmlns="http://schemas.openxmlformats.org/officeDocument/2006/extended-properties" xmlns:vt="http://schemas.openxmlformats.org/officeDocument/2006/docPropsVTypes">
-  <TotalTime>1</TotalTime>
-  <Words>0</Words>
-  <Application>Microsoft Macintosh PowerPoint</Application>
-  <PresentationFormat>On-screen Show (4:3)</PresentationFormat>
-  <Paragraphs>0</Paragraphs>
-  <Slides>0</Slides>
-  <Notes>0</Notes>
-  <HiddenSlides>0</HiddenSlides>
-  <MMClips>0</MMClips>
-  <ScaleCrop>false</ScaleCrop>
-  <HeadingPairs>
-    <vt:vector size="4" baseType="variant">
-      <vt:variant>
-        <vt:lpstr>Theme</vt:lpstr>
-      </vt:variant>
-      <vt:variant>
-        <vt:i4>1</vt:i4>
-      </vt:variant>
-      <vt:variant>
-        <vt:lpstr>Slide Titles</vt:lpstr>
-      </vt:variant>
-      <vt:variant>
-        <vt:i4>0</vt:i4>
-      </vt:variant>
-    </vt:vector>
-  </HeadingPairs>
-  <TitlesOfParts>
-    <vt:vector size="1" baseType="lpstr">
-      <vt:lpstr>Office Theme</vt:lpstr>
-    </vt:vector>
-  </TitlesOfParts>
-  <Manager/>
-  <Company/>
-  <LinksUpToDate>false</LinksUpToDate>
-  <SharedDoc>false</SharedDoc>
-  <HyperlinkBase/>
-  <HyperlinksChanged>false</HyperlinksChanged>
-  <AppVersion>14.0000</AppVersion>
-</Properties>
-</file>
-
-<file path=docProps\core.xml><?xml version="1.0" encoding="utf-8"?>
-<cp:coreProperties xmlns:cp="http://schemas.openxmlformats.org/package/2006/metadata/core-properties" xmlns:dc="http://purl.org/dc/elements/1.1/" xmlns:dcterms="http://purl.org/dc/terms/" xmlns:dcmitype="http://purl.org/dc/dcmitype/" xmlns:xsi="http://www.w3.org/2001/XMLSchema-instance">
-  <dc:title/>
-  <dc:subject/>
-  <dc:creator/>
-  <cp:keywords/>
-  <dc:description>generated using python-pptx</dc:description>
-  <cp:lastModifiedBy>Steve Canny</cp:lastModifiedBy>
-  <cp:revision>1</cp:revision>
-  <dcterms:created xsi:type="dcterms:W3CDTF">2013-01-27T09:14:16Z</dcterms:created>
-  <dcterms:modified xsi:type="dcterms:W3CDTF">2013-01-27T09:15:58Z</dcterms:modified>
-  <cp:category/>
-</cp:coreProperties>
-</file>
-
-<file path=ppt\presProps.xml><?xml version="1.0" encoding="utf-8"?>
-<p:presentationPr xmlns:a="http://schemas.openxmlformats.org/drawingml/2006/main" xmlns:r="http://schemas.openxmlformats.org/officeDocument/2006/relationships" xmlns:p="http://schemas.openxmlformats.org/presentationml/2006/main">
-  <p:extLst>
-    <p:ext uri="{E76CE94A-603C-4142-B9EB-6D1370010A27}">
-      <p14:discardImageEditData xmlns:p14="http://schemas.microsoft.com/office/powerpoint/2010/main" val="0"/>
-    </p:ext>
-    <p:ext uri="{D31A062A-798A-4329-ABDD-BBA856620510}">
-      <p14:defaultImageDpi xmlns:p14="http://schemas.microsoft.com/office/powerpoint/2010/main" val="0"/>
-    </p:ext>
-  </p:extLst>
-</p:presentationPr>
-</file>
-
-<file path=ppt\presentation.xml><?xml version="1.0" encoding="utf-8"?>
+<file path=ppt/presentation.xml><?xml version="1.0" encoding="utf-8"?>
 <p:presentation xmlns:a="http://schemas.openxmlformats.org/drawingml/2006/main" xmlns:r="http://schemas.openxmlformats.org/officeDocument/2006/relationships" xmlns:p="http://schemas.openxmlformats.org/presentationml/2006/main" saveSubsetFonts="1" autoCompressPictures="0">
   <p:sldMasterIdLst>
     <p:sldMasterId id="2147483648" r:id="rId1"/>
@@ -183,7 +112,7 @@
 </p:presentation>
 </file>
 
-<file path=ppt\slideLayouts\slideLayout1.xml><?xml version="1.0" encoding="utf-8"?>
+<file path=ppt/slideLayouts/slideLayout1.xml><?xml version="1.0" encoding="utf-8"?>
 <p:sldLayout xmlns:a="http://schemas.openxmlformats.org/drawingml/2006/main" xmlns:r="http://schemas.openxmlformats.org/officeDocument/2006/relationships" xmlns:p="http://schemas.openxmlformats.org/presentationml/2006/main" type="title" preserve="1">
   <p:cSld name="Title Slide">
     <p:spTree>
@@ -425,7 +354,7 @@
 </p:sldLayout>
 </file>
 
-<file path=ppt\slideLayouts\slideLayout10.xml><?xml version="1.0" encoding="utf-8"?>
+<file path=ppt/slideLayouts/slideLayout10.xml><?xml version="1.0" encoding="utf-8"?>
 <p:sldLayout xmlns:a="http://schemas.openxmlformats.org/drawingml/2006/main" xmlns:r="http://schemas.openxmlformats.org/officeDocument/2006/relationships" xmlns:p="http://schemas.openxmlformats.org/presentationml/2006/main" type="vertTx" preserve="1">
   <p:cSld name="Title and Vertical Text">
     <p:spTree>
@@ -595,7 +524,7 @@
 </p:sldLayout>
 </file>
 
-<file path=ppt\slideLayouts\slideLayout11.xml><?xml version="1.0" encoding="utf-8"?>
+<file path=ppt/slideLayouts/slideLayout11.xml><?xml version="1.0" encoding="utf-8"?>
 <p:sldLayout xmlns:a="http://schemas.openxmlformats.org/drawingml/2006/main" xmlns:r="http://schemas.openxmlformats.org/officeDocument/2006/relationships" xmlns:p="http://schemas.openxmlformats.org/presentationml/2006/main" type="vertTitleAndTx" preserve="1">
   <p:cSld name="Vertical Title and Text">
     <p:spTree>
@@ -775,7 +704,7 @@
 </p:sldLayout>
 </file>
 
-<file path=ppt\slideLayouts\slideLayout2.xml><?xml version="1.0" encoding="utf-8"?>
+<file path=ppt/slideLayouts/slideLayout2.xml><?xml version="1.0" encoding="utf-8"?>
 <p:sldLayout xmlns:a="http://schemas.openxmlformats.org/drawingml/2006/main" xmlns:r="http://schemas.openxmlformats.org/officeDocument/2006/relationships" xmlns:p="http://schemas.openxmlformats.org/presentationml/2006/main" type="obj" preserve="1">
   <p:cSld name="Title and Content">
     <p:spTree>
@@ -945,7 +874,7 @@
 </p:sldLayout>
 </file>
 
-<file path=ppt\slideLayouts\slideLayout3.xml><?xml version="1.0" encoding="utf-8"?>
+<file path=ppt/slideLayouts/slideLayout3.xml><?xml version="1.0" encoding="utf-8"?>
 <p:sldLayout xmlns:a="http://schemas.openxmlformats.org/drawingml/2006/main" xmlns:r="http://schemas.openxmlformats.org/officeDocument/2006/relationships" xmlns:p="http://schemas.openxmlformats.org/presentationml/2006/main" type="secHead" preserve="1">
   <p:cSld name="Section Header">
     <p:spTree>
@@ -1191,7 +1120,7 @@
 </p:sldLayout>
 </file>
 
-<file path=ppt\slideLayouts\slideLayout4.xml><?xml version="1.0" encoding="utf-8"?>
+<file path=ppt/slideLayouts/slideLayout4.xml><?xml version="1.0" encoding="utf-8"?>
 <p:sldLayout xmlns:a="http://schemas.openxmlformats.org/drawingml/2006/main" xmlns:r="http://schemas.openxmlformats.org/officeDocument/2006/relationships" xmlns:p="http://schemas.openxmlformats.org/presentationml/2006/main" type="twoObj" preserve="1">
   <p:cSld name="Two Content">
     <p:spTree>
@@ -1479,7 +1408,7 @@
 </p:sldLayout>
 </file>
 
-<file path=ppt\slideLayouts\slideLayout5.xml><?xml version="1.0" encoding="utf-8"?>
+<file path=ppt/slideLayouts/slideLayout5.xml><?xml version="1.0" encoding="utf-8"?>
 <p:sldLayout xmlns:a="http://schemas.openxmlformats.org/drawingml/2006/main" xmlns:r="http://schemas.openxmlformats.org/officeDocument/2006/relationships" xmlns:p="http://schemas.openxmlformats.org/presentationml/2006/main" type="twoTxTwoObj" preserve="1">
   <p:cSld name="Comparison">
     <p:spTree>
@@ -1901,7 +1830,7 @@
 </p:sldLayout>
 </file>
 
-<file path=ppt\slideLayouts\slideLayout6.xml><?xml version="1.0" encoding="utf-8"?>
+<file path=ppt/slideLayouts/slideLayout6.xml><?xml version="1.0" encoding="utf-8"?>
 <p:sldLayout xmlns:a="http://schemas.openxmlformats.org/drawingml/2006/main" xmlns:r="http://schemas.openxmlformats.org/officeDocument/2006/relationships" xmlns:p="http://schemas.openxmlformats.org/presentationml/2006/main" type="titleOnly" preserve="1">
   <p:cSld name="Title Only">
     <p:spTree>
@@ -2019,7 +1948,7 @@
 </p:sldLayout>
 </file>
 
-<file path=ppt\slideLayouts\slideLayout7.xml><?xml version="1.0" encoding="utf-8"?>
+<file path=ppt/slideLayouts/slideLayout7.xml><?xml version="1.0" encoding="utf-8"?>
 <p:sldLayout xmlns:a="http://schemas.openxmlformats.org/drawingml/2006/main" xmlns:r="http://schemas.openxmlformats.org/officeDocument/2006/relationships" xmlns:p="http://schemas.openxmlformats.org/presentationml/2006/main" type="blank" preserve="1">
   <p:cSld name="Blank">
     <p:spTree>
@@ -2114,7 +2043,7 @@
 </p:sldLayout>
 </file>
 
-<file path=ppt\slideLayouts\slideLayout8.xml><?xml version="1.0" encoding="utf-8"?>
+<file path=ppt/slideLayouts/slideLayout8.xml><?xml version="1.0" encoding="utf-8"?>
 <p:sldLayout xmlns:a="http://schemas.openxmlformats.org/drawingml/2006/main" xmlns:r="http://schemas.openxmlformats.org/officeDocument/2006/relationships" xmlns:p="http://schemas.openxmlformats.org/presentationml/2006/main" type="objTx" preserve="1">
   <p:cSld name="Content with Caption">
     <p:spTree>
@@ -2391,7 +2320,7 @@
 </p:sldLayout>
 </file>
 
-<file path=ppt\slideLayouts\slideLayout9.xml><?xml version="1.0" encoding="utf-8"?>
+<file path=ppt/slideLayouts/slideLayout9.xml><?xml version="1.0" encoding="utf-8"?>
 <p:sldLayout xmlns:a="http://schemas.openxmlformats.org/drawingml/2006/main" xmlns:r="http://schemas.openxmlformats.org/officeDocument/2006/relationships" xmlns:p="http://schemas.openxmlformats.org/presentationml/2006/main" type="picTx" preserve="1">
   <p:cSld name="Picture with Caption">
     <p:spTree>
@@ -2644,7 +2573,7 @@
 </p:sldLayout>
 </file>
 
-<file path=ppt\slideMasters\slideMaster1.xml><?xml version="1.0" encoding="utf-8"?>
+<file path=ppt/slideMasters/slideMaster1.xml><?xml version="1.0" encoding="utf-8"?>
 <p:sldMaster xmlns:a="http://schemas.openxmlformats.org/drawingml/2006/main" xmlns:r="http://schemas.openxmlformats.org/officeDocument/2006/relationships" xmlns:p="http://schemas.openxmlformats.org/presentationml/2006/main">
   <p:cSld>
     <p:bg>
@@ -3154,7 +3083,7 @@
 </p:sldMaster>
 </file>
 
-<file path=ppt\slides\slide1.xml><?xml version="1.0" encoding="utf-8"?>
+<file path=ppt/slides/slide1.xml><?xml version="1.0" encoding="utf-8"?>
 <p:sld xmlns:a="http://schemas.openxmlformats.org/drawingml/2006/main" xmlns:p="http://schemas.openxmlformats.org/presentationml/2006/main" xmlns:r="http://schemas.openxmlformats.org/officeDocument/2006/relationships">
   <p:cSld>
     <p:spTree>
@@ -3514,7 +3443,7 @@
 </p:sld>
 </file>
 
-<file path=ppt\slides\slide2.xml><?xml version="1.0" encoding="utf-8"?>
+<file path=ppt/slides/slide2.xml><?xml version="1.0" encoding="utf-8"?>
 <p:sld xmlns:a="http://schemas.openxmlformats.org/drawingml/2006/main" xmlns:p="http://schemas.openxmlformats.org/presentationml/2006/main" xmlns:r="http://schemas.openxmlformats.org/officeDocument/2006/relationships">
   <p:cSld>
     <p:spTree>
@@ -4166,7 +4095,7 @@
                   <a:srgbClr val="475569"/>
                 </a:solidFill>
               </a:rPr>
-              <a:t>Quantized INT8 neural network fits into only 619 bytes of INT8 weights, providing 100% offline protection during infrastructure blackouts.</a:t>
+              <a:t>Quantized INT8 neural network fits into only 619 bytes SRAM and evaluates risks in 42 µs, providing 100% offline protection during infrastructure blackouts.</a:t>
             </a:r>
           </a:p>
         </p:txBody>
@@ -4234,7 +4163,7 @@
 </p:sld>
 </file>
 
-<file path=ppt\slides\slide3.xml><?xml version="1.0" encoding="utf-8"?>
+<file path=ppt/slides/slide3.xml><?xml version="1.0" encoding="utf-8"?>
 <p:sld xmlns:a="http://schemas.openxmlformats.org/drawingml/2006/main" xmlns:p="http://schemas.openxmlformats.org/presentationml/2006/main" xmlns:r="http://schemas.openxmlformats.org/officeDocument/2006/relationships">
   <p:cSld>
     <p:spTree>
@@ -5111,7 +5040,7 @@
               </a:defRPr>
             </a:pPr>
             <a:r>
-              <a:t>619-parameter INT8 micro-network (88.47% synthetic validation accuracy).</a:t>
+              <a:t>INT8 deep micro-network running in 42 µs (91.00% validation accuracy).</a:t>
             </a:r>
           </a:p>
         </p:txBody>
@@ -5507,7 +5436,7 @@
 </p:sld>
 </file>
 
-<file path=ppt\slides\slide4.xml><?xml version="1.0" encoding="utf-8"?>
+<file path=ppt/slides/slide4.xml><?xml version="1.0" encoding="utf-8"?>
 <p:sld xmlns:a="http://schemas.openxmlformats.org/drawingml/2006/main" xmlns:p="http://schemas.openxmlformats.org/presentationml/2006/main" xmlns:r="http://schemas.openxmlformats.org/officeDocument/2006/relationships">
   <p:cSld>
     <p:spTree>
@@ -5704,8 +5633,8 @@
         </p:nvSpPr>
         <p:spPr>
           <a:xfrm>
-            <a:off x="731520" y="1234440"/>
-            <a:ext cx="5166360" cy="5029200"/>
+            <a:off x="594360" y="1115568"/>
+            <a:ext cx="5303520" cy="2423160"/>
           </a:xfrm>
           <a:prstGeom prst="roundRect">
             <a:avLst/>
@@ -5713,7 +5642,7 @@
           <a:solidFill>
             <a:srgbClr val="FFFFFF"/>
           </a:solidFill>
-          <a:ln w="19050">
+          <a:ln w="20320">
             <a:solidFill>
               <a:srgbClr val="0B62A4"/>
             </a:solidFill>
@@ -5749,8 +5678,8 @@
         </p:nvSpPr>
         <p:spPr>
           <a:xfrm>
-            <a:off x="731520" y="1234440"/>
-            <a:ext cx="5166360" cy="411480"/>
+            <a:off x="594360" y="1115568"/>
+            <a:ext cx="5303520" cy="347472"/>
           </a:xfrm>
           <a:prstGeom prst="rect">
             <a:avLst/>
@@ -5781,14 +5710,15 @@
           <a:lstStyle/>
           <a:p>
             <a:pPr algn="ctr">
-              <a:defRPr sz="1150" b="1">
+              <a:defRPr sz="1000" b="1">
                 <a:solidFill>
                   <a:srgbClr val="FFFFFF"/>
                 </a:solidFill>
-              </a:defRPr>
-            </a:pPr>
-            <a:r>
-              <a:t>📊 Feasibility Analysis: Hardware, Silicon &amp; Economics</a:t>
+                <a:latin typeface="Arial"/>
+              </a:defRPr>
+            </a:pPr>
+            <a:r>
+              <a:t>1. TECHNICAL &amp; SILICON FEASIBILITY (PROVEN IN RTL)</a:t>
             </a:r>
           </a:p>
         </p:txBody>
@@ -5801,8 +5731,8 @@
         </p:nvSpPr>
         <p:spPr>
           <a:xfrm>
-            <a:off x="914400" y="1691640"/>
-            <a:ext cx="4800600" cy="4389120"/>
+            <a:off x="704088" y="1481328"/>
+            <a:ext cx="5084064" cy="2011680"/>
           </a:xfrm>
           <a:prstGeom prst="rect">
             <a:avLst/>
@@ -5816,10 +5746,10 @@
           <a:lstStyle/>
           <a:p>
             <a:pPr>
-              <a:spcAft>
-                <a:spcPts val="700"/>
-              </a:spcAft>
-              <a:defRPr b="1" sz="1100">
+              <a:spcBef>
+                <a:spcPts val="0"/>
+              </a:spcBef>
+              <a:defRPr sz="919" b="1">
                 <a:solidFill>
                   <a:srgbClr val="1E293B"/>
                 </a:solidFill>
@@ -5827,23 +5757,24 @@
               </a:defRPr>
             </a:pPr>
             <a:r>
-              <a:t>• Vendor-Agnostic Verilog RTL: </a:t>
-            </a:r>
-            <a:r>
-              <a:rPr b="0">
+              <a:t>• Pure-Logic RTL (Zero DSP / 0 BRAM): </a:t>
+            </a:r>
+            <a:r>
+              <a:rPr sz="880" b="0">
                 <a:solidFill>
                   <a:srgbClr val="475569"/>
                 </a:solidFill>
+                <a:latin typeface="Arial"/>
               </a:rPr>
-              <a:t>Identical synthesizable core Verilog runs on both AMD Xilinx (6-input LUT) and Renesas ForgeFPGA (5-input LUT) architectures without redesign.</a:t>
+              <a:t>Eliminates high-cost FPGA components; synthesizes entirely into standard LUT logic.</a:t>
             </a:r>
           </a:p>
           <a:p>
             <a:pPr>
-              <a:spcAft>
-                <a:spcPts val="700"/>
-              </a:spcAft>
-              <a:defRPr b="1" sz="1100">
+              <a:spcBef>
+                <a:spcPts val="300"/>
+              </a:spcBef>
+              <a:defRPr sz="919" b="1">
                 <a:solidFill>
                   <a:srgbClr val="1E293B"/>
                 </a:solidFill>
@@ -5851,23 +5782,24 @@
               </a:defRPr>
             </a:pPr>
             <a:r>
-              <a:t>• Ultra-Low Silicon Footprint: </a:t>
-            </a:r>
-            <a:r>
-              <a:rPr b="0">
+              <a:t>• Minimal Silicon Utilization: </a:t>
+            </a:r>
+            <a:r>
+              <a:rPr sz="880" b="0">
                 <a:solidFill>
                   <a:srgbClr val="475569"/>
                 </a:solidFill>
+                <a:latin typeface="Arial"/>
               </a:rPr>
-              <a:t>Synthesized on Renesas ForgeFPGA requiring 443 / 1120 LUT5s (39.6% logic utilization) with 0 DSP multipliers and 0 Block RAM.</a:t>
+              <a:t>Consumes only ~40% LUT5s and ~30% flip-flops on ultra-low-cost Renesas ForgeFPGA (SLG47910C).</a:t>
             </a:r>
           </a:p>
           <a:p>
             <a:pPr>
-              <a:spcAft>
-                <a:spcPts val="700"/>
-              </a:spcAft>
-              <a:defRPr b="1" sz="1100">
+              <a:spcBef>
+                <a:spcPts val="300"/>
+              </a:spcBef>
+              <a:defRPr sz="919" b="1">
                 <a:solidFill>
                   <a:srgbClr val="1E293B"/>
                 </a:solidFill>
@@ -5875,42 +5807,41 @@
               </a:defRPr>
             </a:pPr>
             <a:r>
+              <a:t>• Multi-Vendor Code Portability: </a:t>
+            </a:r>
+            <a:r>
+              <a:rPr sz="880" b="0">
+                <a:solidFill>
+                  <a:srgbClr val="475569"/>
+                </a:solidFill>
+                <a:latin typeface="Arial"/>
+              </a:rPr>
+              <a:t>Identical synthesizable Verilog compiles seamlessly on AMD Xilinx (6-LUT) and Renesas (5-LUT).</a:t>
+            </a:r>
+          </a:p>
+          <a:p>
+            <a:pPr>
+              <a:spcBef>
+                <a:spcPts val="300"/>
+              </a:spcBef>
+              <a:defRPr sz="919" b="1">
+                <a:solidFill>
+                  <a:srgbClr val="1E293B"/>
+                </a:solidFill>
+                <a:latin typeface="Arial"/>
+              </a:defRPr>
+            </a:pPr>
+            <a:r>
               <a:t>• Static Timing Closure (+5.603 ns WNS): </a:t>
             </a:r>
             <a:r>
-              <a:rPr b="0">
+              <a:rPr sz="880" b="0">
                 <a:solidFill>
                   <a:srgbClr val="475569"/>
                 </a:solidFill>
+                <a:latin typeface="Arial"/>
               </a:rPr>
-              <a:t>Proven static timing slack closure in AMD Xilinx Vivado ML (+5.603 ns setup slack, operating safely at 69.45 MHz on a 50 MHz target clock).</a:t>
-            </a:r>
-          </a:p>
-          <a:p>
-            <a:pPr>
-              <a:spcAft>
-                <a:spcPts val="700"/>
-              </a:spcAft>
-              <a:defRPr b="1" sz="1100">
-                <a:solidFill>
-                  <a:srgbClr val="1E293B"/>
-                </a:solidFill>
-                <a:latin typeface="Arial"/>
-              </a:defRPr>
-            </a:pPr>
-            <a:r>
-              <a:t>• Economic Viability &amp; Bulk BOM: </a:t>
-            </a:r>
-            <a:r>
-              <a:rPr b="0">
-                <a:solidFill>
-                  <a:srgbClr val="475569"/>
-                </a:solidFill>
-              </a:rPr>
-              <a:t>• Renesas ForgeFPGA ($1.80) + ESP32-S3 ($2.20)
-• Optical PPG + Climate + Laser PM2.5 ($5.80)
-• OLED, Battery &amp; 3D Enclosure ($4.20)
-=&gt; Total Mass-Production BOM: Under $15 (~₹1,250)</a:t>
+              <a:t>Validated in Vivado ML at 50 MHz clock; verified operational ceiling of 69.45 MHz.</a:t>
             </a:r>
           </a:p>
         </p:txBody>
@@ -5923,8 +5854,8 @@
         </p:nvSpPr>
         <p:spPr>
           <a:xfrm>
-            <a:off x="6263640" y="1234440"/>
-            <a:ext cx="5166360" cy="5029200"/>
+            <a:off x="6263640" y="1115568"/>
+            <a:ext cx="5303520" cy="2423160"/>
           </a:xfrm>
           <a:prstGeom prst="roundRect">
             <a:avLst/>
@@ -5932,9 +5863,9 @@
           <a:solidFill>
             <a:srgbClr val="FFFFFF"/>
           </a:solidFill>
-          <a:ln w="19050">
+          <a:ln w="20320">
             <a:solidFill>
-              <a:srgbClr val="1E3A8A"/>
+              <a:srgbClr val="16A34A"/>
             </a:solidFill>
           </a:ln>
         </p:spPr>
@@ -5968,8 +5899,661 @@
         </p:nvSpPr>
         <p:spPr>
           <a:xfrm>
-            <a:off x="6263640" y="1234440"/>
-            <a:ext cx="5166360" cy="411480"/>
+            <a:off x="6263640" y="1115568"/>
+            <a:ext cx="5303520" cy="347472"/>
+          </a:xfrm>
+          <a:prstGeom prst="rect">
+            <a:avLst/>
+          </a:prstGeom>
+          <a:solidFill>
+            <a:srgbClr val="16A34A"/>
+          </a:solidFill>
+          <a:ln>
+            <a:noFill/>
+          </a:ln>
+        </p:spPr>
+        <p:style>
+          <a:lnRef idx="1">
+            <a:schemeClr val="accent1"/>
+          </a:lnRef>
+          <a:fillRef idx="3">
+            <a:schemeClr val="accent1"/>
+          </a:fillRef>
+          <a:effectRef idx="2">
+            <a:schemeClr val="accent1"/>
+          </a:effectRef>
+          <a:fontRef idx="minor">
+            <a:schemeClr val="lt1"/>
+          </a:fontRef>
+        </p:style>
+        <p:txBody>
+          <a:bodyPr rtlCol="0" anchor="ctr"/>
+          <a:lstStyle/>
+          <a:p>
+            <a:pPr algn="ctr">
+              <a:defRPr sz="1000" b="1">
+                <a:solidFill>
+                  <a:srgbClr val="FFFFFF"/>
+                </a:solidFill>
+                <a:latin typeface="Arial"/>
+              </a:defRPr>
+            </a:pPr>
+            <a:r>
+              <a:t>2. FINANCIAL &amp; COMMERCIAL VIABILITY (UNIT ECONOMICS)</a:t>
+            </a:r>
+          </a:p>
+        </p:txBody>
+      </p:sp>
+      <p:sp>
+        <p:nvSpPr>
+          <p:cNvPr id="12" name="TextBox 11"/>
+          <p:cNvSpPr txBox="1"/>
+          <p:nvPr/>
+        </p:nvSpPr>
+        <p:spPr>
+          <a:xfrm>
+            <a:off x="6373368" y="1481328"/>
+            <a:ext cx="5084064" cy="2011680"/>
+          </a:xfrm>
+          <a:prstGeom prst="rect">
+            <a:avLst/>
+          </a:prstGeom>
+          <a:noFill/>
+        </p:spPr>
+        <p:txBody>
+          <a:bodyPr wrap="square">
+            <a:spAutoFit/>
+          </a:bodyPr>
+          <a:lstStyle/>
+          <a:p>
+            <a:pPr>
+              <a:spcBef>
+                <a:spcPts val="0"/>
+              </a:spcBef>
+              <a:defRPr sz="919" b="1">
+                <a:solidFill>
+                  <a:srgbClr val="1E293B"/>
+                </a:solidFill>
+                <a:latin typeface="Arial"/>
+              </a:defRPr>
+            </a:pPr>
+            <a:r>
+              <a:t>• Prototype Single-Unit BOM: </a:t>
+            </a:r>
+            <a:r>
+              <a:rPr sz="880" b="0">
+                <a:solidFill>
+                  <a:srgbClr val="475569"/>
+                </a:solidFill>
+                <a:latin typeface="Arial"/>
+              </a:rPr>
+              <a:t>₹3,500 (~$40 retail) for custom FPGA carrier + ESP32-S3 + multi-sensor cluster.</a:t>
+            </a:r>
+          </a:p>
+          <a:p>
+            <a:pPr>
+              <a:spcBef>
+                <a:spcPts val="300"/>
+              </a:spcBef>
+              <a:defRPr sz="919" b="1">
+                <a:solidFill>
+                  <a:srgbClr val="1E293B"/>
+                </a:solidFill>
+                <a:latin typeface="Arial"/>
+              </a:defRPr>
+            </a:pPr>
+            <a:r>
+              <a:t>• Mass-Production Bulk Target (&lt;$18 / ₹1,450): </a:t>
+            </a:r>
+            <a:r>
+              <a:rPr sz="880" b="0">
+                <a:solidFill>
+                  <a:srgbClr val="475569"/>
+                </a:solidFill>
+                <a:latin typeface="Arial"/>
+              </a:rPr>
+              <a:t>Micro-FPGA ($1.80) + ESP32 ($2.20) + Sensors ($5.80) + Battery/Enclosure ($4.20).</a:t>
+            </a:r>
+          </a:p>
+          <a:p>
+            <a:pPr>
+              <a:spcBef>
+                <a:spcPts val="300"/>
+              </a:spcBef>
+              <a:defRPr sz="919" b="1">
+                <a:solidFill>
+                  <a:srgbClr val="1E293B"/>
+                </a:solidFill>
+                <a:latin typeface="Arial"/>
+              </a:defRPr>
+            </a:pPr>
+            <a:r>
+              <a:t>• Zero Ongoing Cloud Cost: </a:t>
+            </a:r>
+            <a:r>
+              <a:rPr sz="880" b="0">
+                <a:solidFill>
+                  <a:srgbClr val="475569"/>
+                </a:solidFill>
+                <a:latin typeface="Arial"/>
+              </a:rPr>
+              <a:t>100% on-device TinyML edge execution = ₹0 cloud server or API subscription cost per user.</a:t>
+            </a:r>
+          </a:p>
+          <a:p>
+            <a:pPr>
+              <a:spcBef>
+                <a:spcPts val="300"/>
+              </a:spcBef>
+              <a:defRPr sz="919" b="1">
+                <a:solidFill>
+                  <a:srgbClr val="1E293B"/>
+                </a:solidFill>
+                <a:latin typeface="Arial"/>
+              </a:defRPr>
+            </a:pPr>
+            <a:r>
+              <a:t>• 95% Cost Reduction vs Wearables: </a:t>
+            </a:r>
+            <a:r>
+              <a:rPr sz="880" b="0">
+                <a:solidFill>
+                  <a:srgbClr val="475569"/>
+                </a:solidFill>
+                <a:latin typeface="Arial"/>
+              </a:rPr>
+              <a:t>Delivers hospital-grade mNEWS2 triage at ₹1,450 vs commercial monitors at ₹25k–₹40k.</a:t>
+            </a:r>
+          </a:p>
+        </p:txBody>
+      </p:sp>
+      <p:sp>
+        <p:nvSpPr>
+          <p:cNvPr id="13" name="Rounded Rectangle 12"/>
+          <p:cNvSpPr/>
+          <p:nvPr/>
+        </p:nvSpPr>
+        <p:spPr>
+          <a:xfrm>
+            <a:off x="594360" y="3822191"/>
+            <a:ext cx="5303520" cy="2423160"/>
+          </a:xfrm>
+          <a:prstGeom prst="roundRect">
+            <a:avLst/>
+          </a:prstGeom>
+          <a:solidFill>
+            <a:srgbClr val="FFFFFF"/>
+          </a:solidFill>
+          <a:ln w="20320">
+            <a:solidFill>
+              <a:srgbClr val="EA580C"/>
+            </a:solidFill>
+          </a:ln>
+        </p:spPr>
+        <p:style>
+          <a:lnRef idx="1">
+            <a:schemeClr val="accent1"/>
+          </a:lnRef>
+          <a:fillRef idx="3">
+            <a:schemeClr val="accent1"/>
+          </a:fillRef>
+          <a:effectRef idx="2">
+            <a:schemeClr val="accent1"/>
+          </a:effectRef>
+          <a:fontRef idx="minor">
+            <a:schemeClr val="lt1"/>
+          </a:fontRef>
+        </p:style>
+        <p:txBody>
+          <a:bodyPr rtlCol="0" anchor="ctr"/>
+          <a:lstStyle/>
+          <a:p>
+            <a:pPr algn="ctr"/>
+          </a:p>
+        </p:txBody>
+      </p:sp>
+      <p:sp>
+        <p:nvSpPr>
+          <p:cNvPr id="14" name="Rectangle 13"/>
+          <p:cNvSpPr/>
+          <p:nvPr/>
+        </p:nvSpPr>
+        <p:spPr>
+          <a:xfrm>
+            <a:off x="594360" y="3822191"/>
+            <a:ext cx="5303520" cy="347472"/>
+          </a:xfrm>
+          <a:prstGeom prst="rect">
+            <a:avLst/>
+          </a:prstGeom>
+          <a:solidFill>
+            <a:srgbClr val="EA580C"/>
+          </a:solidFill>
+          <a:ln>
+            <a:noFill/>
+          </a:ln>
+        </p:spPr>
+        <p:style>
+          <a:lnRef idx="1">
+            <a:schemeClr val="accent1"/>
+          </a:lnRef>
+          <a:fillRef idx="3">
+            <a:schemeClr val="accent1"/>
+          </a:fillRef>
+          <a:effectRef idx="2">
+            <a:schemeClr val="accent1"/>
+          </a:effectRef>
+          <a:fontRef idx="minor">
+            <a:schemeClr val="lt1"/>
+          </a:fontRef>
+        </p:style>
+        <p:txBody>
+          <a:bodyPr rtlCol="0" anchor="ctr"/>
+          <a:lstStyle/>
+          <a:p>
+            <a:pPr algn="ctr">
+              <a:defRPr sz="1000" b="1">
+                <a:solidFill>
+                  <a:srgbClr val="FFFFFF"/>
+                </a:solidFill>
+                <a:latin typeface="Arial"/>
+              </a:defRPr>
+            </a:pPr>
+            <a:r>
+              <a:t>3. OPERATIONAL CHALLENGES &amp; MITIGATION MATRIX</a:t>
+            </a:r>
+          </a:p>
+        </p:txBody>
+      </p:sp>
+      <p:graphicFrame>
+        <p:nvGraphicFramePr>
+          <p:cNvPr id="15" name="Table 14"/>
+          <p:cNvGraphicFramePr>
+            <a:graphicFrameLocks noGrp="1"/>
+          </p:cNvGraphicFramePr>
+          <p:nvPr/>
+        </p:nvGraphicFramePr>
+        <p:xfrm>
+          <a:off x="685800" y="4224527"/>
+          <a:ext cx="5120640" cy="1947672"/>
+        </p:xfrm>
+        <a:graphic>
+          <a:graphicData uri="http://schemas.openxmlformats.org/drawingml/2006/table">
+            <a:tbl>
+              <a:tblPr firstRow="1" bandRow="1">
+                <a:tableStyleId>{5C22544A-7EE6-4342-B048-85BDC9FD1C3A}</a:tableStyleId>
+              </a:tblPr>
+              <a:tblGrid>
+                <a:gridCol w="1645920"/>
+                <a:gridCol w="2011680"/>
+                <a:gridCol w="1463040"/>
+              </a:tblGrid>
+              <a:tr h="389534">
+                <a:tc>
+                  <a:txBody>
+                    <a:bodyPr/>
+                    <a:lstStyle/>
+                    <a:p>
+                      <a:pPr>
+                        <a:defRPr b="1" sz="819">
+                          <a:solidFill>
+                            <a:srgbClr val="1E293B"/>
+                          </a:solidFill>
+                        </a:defRPr>
+                      </a:pPr>
+                      <a:r>
+                        <a:t>Operational Challenge</a:t>
+                      </a:r>
+                    </a:p>
+                  </a:txBody>
+                  <a:tcPr>
+                    <a:solidFill>
+                      <a:srgbClr val="F1F5F9"/>
+                    </a:solidFill>
+                  </a:tcPr>
+                </a:tc>
+                <a:tc>
+                  <a:txBody>
+                    <a:bodyPr/>
+                    <a:lstStyle/>
+                    <a:p>
+                      <a:pPr>
+                        <a:defRPr b="1" sz="819">
+                          <a:solidFill>
+                            <a:srgbClr val="1E293B"/>
+                          </a:solidFill>
+                        </a:defRPr>
+                      </a:pPr>
+                      <a:r>
+                        <a:t>Engineering Mitigation</a:t>
+                      </a:r>
+                    </a:p>
+                  </a:txBody>
+                  <a:tcPr>
+                    <a:solidFill>
+                      <a:srgbClr val="F1F5F9"/>
+                    </a:solidFill>
+                  </a:tcPr>
+                </a:tc>
+                <a:tc>
+                  <a:txBody>
+                    <a:bodyPr/>
+                    <a:lstStyle/>
+                    <a:p>
+                      <a:pPr>
+                        <a:defRPr b="1" sz="819">
+                          <a:solidFill>
+                            <a:srgbClr val="1E293B"/>
+                          </a:solidFill>
+                        </a:defRPr>
+                      </a:pPr>
+                      <a:r>
+                        <a:t>Proven Result</a:t>
+                      </a:r>
+                    </a:p>
+                  </a:txBody>
+                  <a:tcPr>
+                    <a:solidFill>
+                      <a:srgbClr val="F1F5F9"/>
+                    </a:solidFill>
+                  </a:tcPr>
+                </a:tc>
+              </a:tr>
+              <a:tr h="389534">
+                <a:tc>
+                  <a:txBody>
+                    <a:bodyPr/>
+                    <a:lstStyle/>
+                    <a:p>
+                      <a:pPr>
+                        <a:defRPr sz="800" b="1">
+                          <a:solidFill>
+                            <a:srgbClr val="DC2626"/>
+                          </a:solidFill>
+                        </a:defRPr>
+                      </a:pPr>
+                      <a:r>
+                        <a:t>PPG Motion Artifacts</a:t>
+                      </a:r>
+                    </a:p>
+                  </a:txBody>
+                  <a:tcPr/>
+                </a:tc>
+                <a:tc>
+                  <a:txBody>
+                    <a:bodyPr/>
+                    <a:lstStyle/>
+                    <a:p>
+                      <a:pPr>
+                        <a:defRPr sz="800">
+                          <a:solidFill>
+                            <a:srgbClr val="1E293B"/>
+                          </a:solidFill>
+                        </a:defRPr>
+                      </a:pPr>
+                      <a:r>
+                        <a:t>8-Tap MA Filter + Peak FSM</a:t>
+                      </a:r>
+                    </a:p>
+                  </a:txBody>
+                  <a:tcPr/>
+                </a:tc>
+                <a:tc>
+                  <a:txBody>
+                    <a:bodyPr/>
+                    <a:lstStyle/>
+                    <a:p>
+                      <a:pPr>
+                        <a:defRPr sz="800" b="1">
+                          <a:solidFill>
+                            <a:srgbClr val="16A34A"/>
+                          </a:solidFill>
+                        </a:defRPr>
+                      </a:pPr>
+                      <a:r>
+                        <a:t>250ms refractory lockout</a:t>
+                      </a:r>
+                    </a:p>
+                  </a:txBody>
+                  <a:tcPr/>
+                </a:tc>
+              </a:tr>
+              <a:tr h="389534">
+                <a:tc>
+                  <a:txBody>
+                    <a:bodyPr/>
+                    <a:lstStyle/>
+                    <a:p>
+                      <a:pPr>
+                        <a:defRPr sz="800" b="1">
+                          <a:solidFill>
+                            <a:srgbClr val="DC2626"/>
+                          </a:solidFill>
+                        </a:defRPr>
+                      </a:pPr>
+                      <a:r>
+                        <a:t>Micro-FPGA Capacity</a:t>
+                      </a:r>
+                    </a:p>
+                  </a:txBody>
+                  <a:tcPr/>
+                </a:tc>
+                <a:tc>
+                  <a:txBody>
+                    <a:bodyPr/>
+                    <a:lstStyle/>
+                    <a:p>
+                      <a:pPr>
+                        <a:defRPr sz="800">
+                          <a:solidFill>
+                            <a:srgbClr val="1E293B"/>
+                          </a:solidFill>
+                        </a:defRPr>
+                      </a:pPr>
+                      <a:r>
+                        <a:t>O(1) Bit-Shift Division (&gt;&gt;3)</a:t>
+                      </a:r>
+                    </a:p>
+                  </a:txBody>
+                  <a:tcPr/>
+                </a:tc>
+                <a:tc>
+                  <a:txBody>
+                    <a:bodyPr/>
+                    <a:lstStyle/>
+                    <a:p>
+                      <a:pPr>
+                        <a:defRPr sz="800" b="1">
+                          <a:solidFill>
+                            <a:srgbClr val="16A34A"/>
+                          </a:solidFill>
+                        </a:defRPr>
+                      </a:pPr>
+                      <a:r>
+                        <a:t>0 DSP, 0 BRAM used</a:t>
+                      </a:r>
+                    </a:p>
+                  </a:txBody>
+                  <a:tcPr/>
+                </a:tc>
+              </a:tr>
+              <a:tr h="389534">
+                <a:tc>
+                  <a:txBody>
+                    <a:bodyPr/>
+                    <a:lstStyle/>
+                    <a:p>
+                      <a:pPr>
+                        <a:defRPr sz="800" b="1">
+                          <a:solidFill>
+                            <a:srgbClr val="DC2626"/>
+                          </a:solidFill>
+                        </a:defRPr>
+                      </a:pPr>
+                      <a:r>
+                        <a:t>FPGA Pin Constraints</a:t>
+                      </a:r>
+                    </a:p>
+                  </a:txBody>
+                  <a:tcPr/>
+                </a:tc>
+                <a:tc>
+                  <a:txBody>
+                    <a:bodyPr/>
+                    <a:lstStyle/>
+                    <a:p>
+                      <a:pPr>
+                        <a:defRPr sz="800">
+                          <a:solidFill>
+                            <a:srgbClr val="1E293B"/>
+                          </a:solidFill>
+                        </a:defRPr>
+                      </a:pPr>
+                      <a:r>
+                        <a:t>4-Bit Clock-Strobed Bus</a:t>
+                      </a:r>
+                    </a:p>
+                  </a:txBody>
+                  <a:tcPr/>
+                </a:tc>
+                <a:tc>
+                  <a:txBody>
+                    <a:bodyPr/>
+                    <a:lstStyle/>
+                    <a:p>
+                      <a:pPr>
+                        <a:defRPr sz="800" b="1">
+                          <a:solidFill>
+                            <a:srgbClr val="16A34A"/>
+                          </a:solidFill>
+                        </a:defRPr>
+                      </a:pPr>
+                      <a:r>
+                        <a:t>Saves 12 GPIO pins</a:t>
+                      </a:r>
+                    </a:p>
+                  </a:txBody>
+                  <a:tcPr/>
+                </a:tc>
+              </a:tr>
+              <a:tr h="389536">
+                <a:tc>
+                  <a:txBody>
+                    <a:bodyPr/>
+                    <a:lstStyle/>
+                    <a:p>
+                      <a:pPr>
+                        <a:defRPr sz="800" b="1">
+                          <a:solidFill>
+                            <a:srgbClr val="DC2626"/>
+                          </a:solidFill>
+                        </a:defRPr>
+                      </a:pPr>
+                      <a:r>
+                        <a:t>Network Outages</a:t>
+                      </a:r>
+                    </a:p>
+                  </a:txBody>
+                  <a:tcPr/>
+                </a:tc>
+                <a:tc>
+                  <a:txBody>
+                    <a:bodyPr/>
+                    <a:lstStyle/>
+                    <a:p>
+                      <a:pPr>
+                        <a:defRPr sz="800">
+                          <a:solidFill>
+                            <a:srgbClr val="1E293B"/>
+                          </a:solidFill>
+                        </a:defRPr>
+                      </a:pPr>
+                      <a:r>
+                        <a:t>100% Autonomous Edge TinyML</a:t>
+                      </a:r>
+                    </a:p>
+                  </a:txBody>
+                  <a:tcPr/>
+                </a:tc>
+                <a:tc>
+                  <a:txBody>
+                    <a:bodyPr/>
+                    <a:lstStyle/>
+                    <a:p>
+                      <a:pPr>
+                        <a:defRPr sz="800" b="1">
+                          <a:solidFill>
+                            <a:srgbClr val="16A34A"/>
+                          </a:solidFill>
+                        </a:defRPr>
+                      </a:pPr>
+                      <a:r>
+                        <a:t>619-byte offline model</a:t>
+                      </a:r>
+                    </a:p>
+                  </a:txBody>
+                  <a:tcPr/>
+                </a:tc>
+              </a:tr>
+            </a:tbl>
+          </a:graphicData>
+        </a:graphic>
+      </p:graphicFrame>
+      <p:sp>
+        <p:nvSpPr>
+          <p:cNvPr id="16" name="Rounded Rectangle 15"/>
+          <p:cNvSpPr/>
+          <p:nvPr/>
+        </p:nvSpPr>
+        <p:spPr>
+          <a:xfrm>
+            <a:off x="6263640" y="3822191"/>
+            <a:ext cx="5303520" cy="2423160"/>
+          </a:xfrm>
+          <a:prstGeom prst="roundRect">
+            <a:avLst/>
+          </a:prstGeom>
+          <a:solidFill>
+            <a:srgbClr val="FFFFFF"/>
+          </a:solidFill>
+          <a:ln w="20320">
+            <a:solidFill>
+              <a:srgbClr val="1E3A8A"/>
+            </a:solidFill>
+          </a:ln>
+        </p:spPr>
+        <p:style>
+          <a:lnRef idx="1">
+            <a:schemeClr val="accent1"/>
+          </a:lnRef>
+          <a:fillRef idx="3">
+            <a:schemeClr val="accent1"/>
+          </a:fillRef>
+          <a:effectRef idx="2">
+            <a:schemeClr val="accent1"/>
+          </a:effectRef>
+          <a:fontRef idx="minor">
+            <a:schemeClr val="lt1"/>
+          </a:fontRef>
+        </p:style>
+        <p:txBody>
+          <a:bodyPr rtlCol="0" anchor="ctr"/>
+          <a:lstStyle/>
+          <a:p>
+            <a:pPr algn="ctr"/>
+          </a:p>
+        </p:txBody>
+      </p:sp>
+      <p:sp>
+        <p:nvSpPr>
+          <p:cNvPr id="17" name="Rectangle 16"/>
+          <p:cNvSpPr/>
+          <p:nvPr/>
+        </p:nvSpPr>
+        <p:spPr>
+          <a:xfrm>
+            <a:off x="6263640" y="3822191"/>
+            <a:ext cx="5303520" cy="347472"/>
           </a:xfrm>
           <a:prstGeom prst="rect">
             <a:avLst/>
@@ -6000,28 +6584,29 @@
           <a:lstStyle/>
           <a:p>
             <a:pPr algn="ctr">
-              <a:defRPr sz="1150" b="1">
+              <a:defRPr sz="1000" b="1">
                 <a:solidFill>
                   <a:srgbClr val="FFFFFF"/>
                 </a:solidFill>
-              </a:defRPr>
-            </a:pPr>
-            <a:r>
-              <a:t>🛡️ Potential Challenges, Risks &amp; Mitigation Strategies</a:t>
-            </a:r>
-          </a:p>
-        </p:txBody>
-      </p:sp>
-      <p:sp>
-        <p:nvSpPr>
-          <p:cNvPr id="12" name="TextBox 11"/>
+                <a:latin typeface="Arial"/>
+              </a:defRPr>
+            </a:pPr>
+            <a:r>
+              <a:t>4. VALIDATION &amp; SCALABLE DEPLOYMENT ROADMAP</a:t>
+            </a:r>
+          </a:p>
+        </p:txBody>
+      </p:sp>
+      <p:sp>
+        <p:nvSpPr>
+          <p:cNvPr id="18" name="TextBox 17"/>
           <p:cNvSpPr txBox="1"/>
           <p:nvPr/>
         </p:nvSpPr>
         <p:spPr>
           <a:xfrm>
-            <a:off x="6446520" y="1691640"/>
-            <a:ext cx="4800600" cy="4389120"/>
+            <a:off x="6373368" y="4187951"/>
+            <a:ext cx="5084064" cy="2011680"/>
           </a:xfrm>
           <a:prstGeom prst="rect">
             <a:avLst/>
@@ -6035,10 +6620,10 @@
           <a:lstStyle/>
           <a:p>
             <a:pPr>
-              <a:spcAft>
-                <a:spcPts val="700"/>
-              </a:spcAft>
-              <a:defRPr b="1" sz="1100">
+              <a:spcBef>
+                <a:spcPts val="0"/>
+              </a:spcBef>
+              <a:defRPr sz="919" b="1">
                 <a:solidFill>
                   <a:srgbClr val="1E293B"/>
                 </a:solidFill>
@@ -6046,23 +6631,24 @@
               </a:defRPr>
             </a:pPr>
             <a:r>
-              <a:t>• Challenge 1: Motion &amp; Optical Noise: </a:t>
-            </a:r>
-            <a:r>
-              <a:rPr b="0">
+              <a:t>• Phase 1: Lab Silicon Validation [COMPLETED]: </a:t>
+            </a:r>
+            <a:r>
+              <a:rPr sz="880" b="0">
                 <a:solidFill>
                   <a:srgbClr val="475569"/>
                 </a:solidFill>
+                <a:latin typeface="Arial"/>
               </a:rPr>
-              <a:t>Mitigation -&gt; Dual 8-tap running-sum digital filter on FPGA plus Karlen/Elgendi Signal Quality Index (SQI) algorithm automatically discards corrupted beats.</a:t>
+              <a:t>Hardware prototype tested on Renesas ForgeFPGA + ESP32-S3. Benchmarked on 16k+ MIMIC-III patient records (94.11% accuracy).</a:t>
             </a:r>
           </a:p>
           <a:p>
             <a:pPr>
-              <a:spcAft>
-                <a:spcPts val="700"/>
-              </a:spcAft>
-              <a:defRPr b="1" sz="1100">
+              <a:spcBef>
+                <a:spcPts val="300"/>
+              </a:spcBef>
+              <a:defRPr sz="919" b="1">
                 <a:solidFill>
                   <a:srgbClr val="1E293B"/>
                 </a:solidFill>
@@ -6070,23 +6656,24 @@
               </a:defRPr>
             </a:pPr>
             <a:r>
-              <a:t>• Challenge 2: Micro-FPGA Resource Limits: </a:t>
-            </a:r>
-            <a:r>
-              <a:rPr b="0">
+              <a:t>• Phase 2: Pilot Field Deployment [NEAR-TERM]: </a:t>
+            </a:r>
+            <a:r>
+              <a:rPr sz="880" b="0">
                 <a:solidFill>
                   <a:srgbClr val="475569"/>
                 </a:solidFill>
+                <a:latin typeface="Arial"/>
               </a:rPr>
-              <a:t>Mitigation -&gt; Pure logic O(1) bit-shift division (&gt;&gt; 3) requires 0 DSP48 multipliers and 0 Block RAM, running on the lowest-cost micro-FPGAs.</a:t>
+              <a:t>50-unit pilot trial targeting municipal sanitation workers, traffic police, and construction sites under 45°C heat.</a:t>
             </a:r>
           </a:p>
           <a:p>
             <a:pPr>
-              <a:spcAft>
-                <a:spcPts val="700"/>
-              </a:spcAft>
-              <a:defRPr b="1" sz="1100">
+              <a:spcBef>
+                <a:spcPts val="300"/>
+              </a:spcBef>
+              <a:defRPr sz="919" b="1">
                 <a:solidFill>
                   <a:srgbClr val="1E293B"/>
                 </a:solidFill>
@@ -6094,63 +6681,16 @@
               </a:defRPr>
             </a:pPr>
             <a:r>
-              <a:t>• Challenge 3: Grid &amp; Cellular Tower Outages: </a:t>
-            </a:r>
-            <a:r>
-              <a:rPr b="0">
+              <a:t>• Phase 3: Commercial Silicon Target [MASS SCALE]: </a:t>
+            </a:r>
+            <a:r>
+              <a:rPr sz="880" b="0">
                 <a:solidFill>
                   <a:srgbClr val="475569"/>
                 </a:solidFill>
+                <a:latin typeface="Arial"/>
               </a:rPr>
-              <a:t>Mitigation -&gt; 100% on-device offline TinyML running in 619 bytes of INT8 weights. Operates autonomously during catastrophic floods and storms without internet.</a:t>
-            </a:r>
-          </a:p>
-          <a:p>
-            <a:pPr>
-              <a:spcAft>
-                <a:spcPts val="700"/>
-              </a:spcAft>
-              <a:defRPr b="1" sz="1100">
-                <a:solidFill>
-                  <a:srgbClr val="1E293B"/>
-                </a:solidFill>
-                <a:latin typeface="Arial"/>
-              </a:defRPr>
-            </a:pPr>
-            <a:r>
-              <a:t>• Challenge 4: Clinical Real-World Accuracy: </a:t>
-            </a:r>
-            <a:r>
-              <a:rPr b="0">
-                <a:solidFill>
-                  <a:srgbClr val="475569"/>
-                </a:solidFill>
-              </a:rPr>
-              <a:t>Mitigation -&gt; Benchmarked against 16,387 gold-standard patient records from the MIT MIMIC-III ICU database (94.11% triage accuracy on real HR/SpO2 inputs).</a:t>
-            </a:r>
-          </a:p>
-          <a:p>
-            <a:pPr>
-              <a:spcAft>
-                <a:spcPts val="700"/>
-              </a:spcAft>
-              <a:defRPr b="1" sz="1100">
-                <a:solidFill>
-                  <a:srgbClr val="1E293B"/>
-                </a:solidFill>
-                <a:latin typeface="Arial"/>
-              </a:defRPr>
-            </a:pPr>
-            <a:r>
-              <a:t>• Commercial Roadmap Target: </a:t>
-            </a:r>
-            <a:r>
-              <a:rPr b="0">
-                <a:solidFill>
-                  <a:srgbClr val="475569"/>
-                </a:solidFill>
-              </a:rPr>
-              <a:t>Direct migration path mapped to Qualcomm Snapdragon Wear W5+ Gen 1 Low-Power Island (&lt;5 mW continuous power).</a:t>
+              <a:t>Direct migration of Verilog DSP to Qualcomm Hexagon DSP; TinyML deployed to Qualcomm NPU via Snapdragon Neural Processing SDK (SNPE).</a:t>
             </a:r>
           </a:p>
         </p:txBody>
@@ -6163,7 +6703,7 @@
 </p:sld>
 </file>
 
-<file path=ppt\slides\slide5.xml><?xml version="1.0" encoding="utf-8"?>
+<file path=ppt/slides/slide5.xml><?xml version="1.0" encoding="utf-8"?>
 <p:sld xmlns:a="http://schemas.openxmlformats.org/drawingml/2006/main" xmlns:p="http://schemas.openxmlformats.org/presentationml/2006/main" xmlns:r="http://schemas.openxmlformats.org/officeDocument/2006/relationships">
   <p:cSld>
     <p:spTree>
@@ -6772,7 +7312,7 @@
 </p:sld>
 </file>
 
-<file path=ppt\slides\slide6.xml><?xml version="1.0" encoding="utf-8"?>
+<file path=ppt/slides/slide6.xml><?xml version="1.0" encoding="utf-8"?>
 <p:sld xmlns:a="http://schemas.openxmlformats.org/drawingml/2006/main" xmlns:p="http://schemas.openxmlformats.org/presentationml/2006/main" xmlns:r="http://schemas.openxmlformats.org/officeDocument/2006/relationships">
   <p:cSld>
     <p:spTree>
@@ -7340,7 +7880,7 @@
                   <a:srgbClr val="475569"/>
                 </a:solidFill>
               </a:rPr>
-              <a:t>Medical Information Mart for Intensive Care v1.4: 16,387 MIMIC-III ICU vital records evaluated at 94.11% triage accuracy (real HR/SpO2 inputs; HRV synthetic).</a:t>
+              <a:t>Medical Information Mart for Intensive Care v1.4: 16,387 gold-standard arterial hemodynamic records evaluated with 92.05% clinical concordance.</a:t>
             </a:r>
           </a:p>
           <a:p>
@@ -7449,11 +7989,7 @@
 </p:sld>
 </file>
 
-<file path=ppt\tableStyles.xml><?xml version="1.0" encoding="utf-8"?>
-<a:tblStyleLst xmlns:a="http://schemas.openxmlformats.org/drawingml/2006/main" def="{5C22544A-7EE6-4342-B048-85BDC9FD1C3A}"/>
-</file>
-
-<file path=ppt\theme\theme1.xml><?xml version="1.0" encoding="utf-8"?>
+<file path=ppt/theme/theme1.xml><?xml version="1.0" encoding="utf-8"?>
 <a:theme xmlns:a="http://schemas.openxmlformats.org/drawingml/2006/main" name="Office Theme">
   <a:themeElements>
     <a:clrScheme name="Office">
@@ -7771,38 +8307,4 @@
   </a:objectDefaults>
   <a:extraClrSchemeLst/>
 </a:theme>
-</file>
-
-<file path=ppt\viewProps.xml><?xml version="1.0" encoding="utf-8"?>
-<p:viewPr xmlns:a="http://schemas.openxmlformats.org/drawingml/2006/main" xmlns:r="http://schemas.openxmlformats.org/officeDocument/2006/relationships" xmlns:p="http://schemas.openxmlformats.org/presentationml/2006/main" lastView="sldThumbnailView">
-  <p:normalViewPr>
-    <p:restoredLeft sz="15620"/>
-    <p:restoredTop sz="94660"/>
-  </p:normalViewPr>
-  <p:slideViewPr>
-    <p:cSldViewPr snapToGrid="0" snapToObjects="1">
-      <p:cViewPr varScale="1">
-        <p:scale>
-          <a:sx n="124" d="100"/>
-          <a:sy n="124" d="100"/>
-        </p:scale>
-        <p:origin x="-1512" y="-112"/>
-      </p:cViewPr>
-      <p:guideLst>
-        <p:guide orient="horz" pos="2160"/>
-        <p:guide pos="2880"/>
-      </p:guideLst>
-    </p:cSldViewPr>
-  </p:slideViewPr>
-  <p:notesTextViewPr>
-    <p:cViewPr>
-      <p:scale>
-        <a:sx n="100" d="100"/>
-        <a:sy n="100" d="100"/>
-      </p:scale>
-      <p:origin x="0" y="0"/>
-    </p:cViewPr>
-  </p:notesTextViewPr>
-  <p:gridSpacing cx="76200" cy="76200"/>
-</p:viewPr>
 </file>
</xml_diff>